<commit_message>
Apply Codex final-QA corrections: PDF rendering, glyph normalization, slide-5 Gantt crop
Cover leading fixes, paragraph-accumulator markdown parser (fixes bold
across wrapped lines), ASCII normalization for arrows/box-drawing/math
glyphs, ASCII bullets for clean text extraction, autolink cleanup, and
the slide-5 revised-Gantt crop per Codex's exact spec. All defects
verified gone via pypdf probes and slide re-inspection; 9/9 tests.

Co-Authored-By: Claude Fable 5 <noreply@anthropic.com>
</commit_message>
<xml_diff>
--- a/output/deck/CableTwin_SUPCOM_Final.pptx
+++ b/output/deck/CableTwin_SUPCOM_Final.pptx
@@ -7275,7 +7275,7 @@
       </p:sp>
       <p:pic>
         <p:nvPicPr>
-          <p:cNvPr id="12" name="Picture 11" descr="05-preview-service-gantt.png"/>
+          <p:cNvPr id="12" name="Picture 11" descr="08-full-resolved.png"/>
           <p:cNvPicPr>
             <a:picLocks noChangeAspect="1"/>
           </p:cNvPicPr>
@@ -7283,7 +7283,7 @@
         </p:nvPicPr>
         <p:blipFill>
           <a:blip r:embed="rId2"/>
-          <a:srcRect t="30500" b="6000"/>
+          <a:srcRect l="17708" r="17708" t="36974" b="53865"/>
           <a:stretch>
             <a:fillRect/>
           </a:stretch>

</xml_diff>